<commit_message>
docs: finalize enterprise readiness evidence
</commit_message>
<xml_diff>
--- a/docs/presentation/HsuFamily-Enterprise-Readiness.pptx
+++ b/docs/presentation/HsuFamily-Enterprise-Readiness.pptx
@@ -2,120 +2,25 @@
 <file path=ppt/presentation.xml><?xml version="1.0" encoding="utf-8"?>
 <p:presentation xmlns:p="http://schemas.openxmlformats.org/presentationml/2006/main">
   <p:sldMasterIdLst>
-    <p:sldMasterId xmlns:r="http://schemas.openxmlformats.org/officeDocument/2006/relationships" id="2147483648" r:id="R77816753b7054c82"/>
+    <p:sldMasterId xmlns:r="http://schemas.openxmlformats.org/officeDocument/2006/relationships" id="2147483648" r:id="R711c6a4d5602432f"/>
   </p:sldMasterIdLst>
   <p:notesMasterIdLst>
-    <p:notesMasterId xmlns:r="http://schemas.openxmlformats.org/officeDocument/2006/relationships" r:id="Rf008704331444bc4"/>
+    <p:notesMasterId xmlns:r="http://schemas.openxmlformats.org/officeDocument/2006/relationships" r:id="Re00b15cf4f6543da"/>
   </p:notesMasterIdLst>
   <p:sldIdLst>
-    <p:sldId xmlns:r="http://schemas.openxmlformats.org/officeDocument/2006/relationships" id="256" r:id="Rb52cc5defa4b43fd"/>
-    <p:sldId xmlns:r="http://schemas.openxmlformats.org/officeDocument/2006/relationships" id="257" r:id="R9780e65a89054865"/>
-    <p:sldId xmlns:r="http://schemas.openxmlformats.org/officeDocument/2006/relationships" id="258" r:id="R05e4021838074292"/>
-    <p:sldId xmlns:r="http://schemas.openxmlformats.org/officeDocument/2006/relationships" id="259" r:id="R333e69c82f274b86"/>
-    <p:sldId xmlns:r="http://schemas.openxmlformats.org/officeDocument/2006/relationships" id="260" r:id="Rb94028c74f084f55"/>
-    <p:sldId xmlns:r="http://schemas.openxmlformats.org/officeDocument/2006/relationships" id="261" r:id="R05ebb0c9fe464292"/>
-    <p:sldId xmlns:r="http://schemas.openxmlformats.org/officeDocument/2006/relationships" id="262" r:id="Rb842f0cbfa9244c2"/>
-    <p:sldId xmlns:r="http://schemas.openxmlformats.org/officeDocument/2006/relationships" id="263" r:id="R40eb2d3fd8ac4b85"/>
-    <p:sldId xmlns:r="http://schemas.openxmlformats.org/officeDocument/2006/relationships" id="264" r:id="R28291605a0464553"/>
-    <p:sldId xmlns:r="http://schemas.openxmlformats.org/officeDocument/2006/relationships" id="265" r:id="Rb842a4b6fbdd42ec"/>
+    <p:sldId xmlns:r="http://schemas.openxmlformats.org/officeDocument/2006/relationships" id="256" r:id="Rfc10993ff0a8476d"/>
+    <p:sldId xmlns:r="http://schemas.openxmlformats.org/officeDocument/2006/relationships" id="257" r:id="R3a434781f9f64952"/>
+    <p:sldId xmlns:r="http://schemas.openxmlformats.org/officeDocument/2006/relationships" id="258" r:id="R847367cb470d491c"/>
+    <p:sldId xmlns:r="http://schemas.openxmlformats.org/officeDocument/2006/relationships" id="259" r:id="R89ca257b87b34db2"/>
+    <p:sldId xmlns:r="http://schemas.openxmlformats.org/officeDocument/2006/relationships" id="260" r:id="R99ea59dd10104972"/>
+    <p:sldId xmlns:r="http://schemas.openxmlformats.org/officeDocument/2006/relationships" id="261" r:id="R6279b4285ac74072"/>
+    <p:sldId xmlns:r="http://schemas.openxmlformats.org/officeDocument/2006/relationships" id="262" r:id="Rc12320ae265f4432"/>
+    <p:sldId xmlns:r="http://schemas.openxmlformats.org/officeDocument/2006/relationships" id="263" r:id="Rcc83bbf375904948"/>
+    <p:sldId xmlns:r="http://schemas.openxmlformats.org/officeDocument/2006/relationships" id="264" r:id="R01db592c5c894948"/>
+    <p:sldId xmlns:r="http://schemas.openxmlformats.org/officeDocument/2006/relationships" id="265" r:id="R45a6ee0005d5435e"/>
   </p:sldIdLst>
   <p:sldSz cx="12192000" cy="6858000"/>
   <p:notesSz cx="6858000" cy="9144000"/>
-  <p:defaultTextStyle>
-    <a:defPPr xmlns:a="http://schemas.openxmlformats.org/drawingml/2006/main">
-      <a:defRPr lang="en-US"/>
-    </a:defPPr>
-    <a:lvl1pPr xmlns:a="http://schemas.openxmlformats.org/drawingml/2006/main" marL="0" indent="0" algn="l" defTabSz="914400">
-      <a:defRPr sz="1800" kern="1200">
-        <a:solidFill>
-          <a:schemeClr val="tx1"/>
-        </a:solidFill>
-        <a:latin typeface="+mn-lt"/>
-        <a:ea typeface="+mn-ea"/>
-        <a:cs typeface="+mn-cs"/>
-      </a:defRPr>
-    </a:lvl1pPr>
-    <a:lvl2pPr xmlns:a="http://schemas.openxmlformats.org/drawingml/2006/main" marL="457200" indent="0" algn="l" defTabSz="914400">
-      <a:defRPr sz="1800" kern="1200">
-        <a:solidFill>
-          <a:schemeClr val="tx1"/>
-        </a:solidFill>
-        <a:latin typeface="+mn-lt"/>
-        <a:ea typeface="+mn-ea"/>
-        <a:cs typeface="+mn-cs"/>
-      </a:defRPr>
-    </a:lvl2pPr>
-    <a:lvl3pPr xmlns:a="http://schemas.openxmlformats.org/drawingml/2006/main" marL="914400" indent="0" algn="l" defTabSz="914400">
-      <a:defRPr sz="1800" kern="1200">
-        <a:solidFill>
-          <a:schemeClr val="tx1"/>
-        </a:solidFill>
-        <a:latin typeface="+mn-lt"/>
-        <a:ea typeface="+mn-ea"/>
-        <a:cs typeface="+mn-cs"/>
-      </a:defRPr>
-    </a:lvl3pPr>
-    <a:lvl4pPr xmlns:a="http://schemas.openxmlformats.org/drawingml/2006/main" marL="1371600" indent="0" algn="l" defTabSz="914400">
-      <a:defRPr sz="1800" kern="1200">
-        <a:solidFill>
-          <a:schemeClr val="tx1"/>
-        </a:solidFill>
-        <a:latin typeface="+mn-lt"/>
-        <a:ea typeface="+mn-ea"/>
-        <a:cs typeface="+mn-cs"/>
-      </a:defRPr>
-    </a:lvl4pPr>
-    <a:lvl5pPr xmlns:a="http://schemas.openxmlformats.org/drawingml/2006/main" marL="1828800" indent="0" algn="l" defTabSz="914400">
-      <a:defRPr sz="1800" kern="1200">
-        <a:solidFill>
-          <a:schemeClr val="tx1"/>
-        </a:solidFill>
-        <a:latin typeface="+mn-lt"/>
-        <a:ea typeface="+mn-ea"/>
-        <a:cs typeface="+mn-cs"/>
-      </a:defRPr>
-    </a:lvl5pPr>
-    <a:lvl6pPr xmlns:a="http://schemas.openxmlformats.org/drawingml/2006/main" marL="2286000" indent="0" algn="l" defTabSz="914400">
-      <a:defRPr sz="1800" kern="1200">
-        <a:solidFill>
-          <a:schemeClr val="tx1"/>
-        </a:solidFill>
-        <a:latin typeface="+mn-lt"/>
-        <a:ea typeface="+mn-ea"/>
-        <a:cs typeface="+mn-cs"/>
-      </a:defRPr>
-    </a:lvl6pPr>
-    <a:lvl7pPr xmlns:a="http://schemas.openxmlformats.org/drawingml/2006/main" marL="2743200" indent="0" algn="l" defTabSz="914400">
-      <a:defRPr sz="1800" kern="1200">
-        <a:solidFill>
-          <a:schemeClr val="tx1"/>
-        </a:solidFill>
-        <a:latin typeface="+mn-lt"/>
-        <a:ea typeface="+mn-ea"/>
-        <a:cs typeface="+mn-cs"/>
-      </a:defRPr>
-    </a:lvl7pPr>
-    <a:lvl8pPr xmlns:a="http://schemas.openxmlformats.org/drawingml/2006/main" marL="3200400" indent="0" algn="l" defTabSz="914400">
-      <a:defRPr sz="1800" kern="1200">
-        <a:solidFill>
-          <a:schemeClr val="tx1"/>
-        </a:solidFill>
-        <a:latin typeface="+mn-lt"/>
-        <a:ea typeface="+mn-ea"/>
-        <a:cs typeface="+mn-cs"/>
-      </a:defRPr>
-    </a:lvl8pPr>
-    <a:lvl9pPr xmlns:a="http://schemas.openxmlformats.org/drawingml/2006/main" marL="3657600" indent="0" algn="l" defTabSz="914400">
-      <a:defRPr sz="1800" kern="1200">
-        <a:solidFill>
-          <a:schemeClr val="tx1"/>
-        </a:solidFill>
-        <a:latin typeface="+mn-lt"/>
-        <a:ea typeface="+mn-ea"/>
-        <a:cs typeface="+mn-cs"/>
-      </a:defRPr>
-    </a:lvl9pPr>
-  </p:defaultTextStyle>
 </p:presentation>
 </file>
 
@@ -544,7 +449,31 @@
         <p:txBody>
           <a:bodyPr xmlns:a="http://schemas.openxmlformats.org/drawingml/2006/main"/>
           <a:lstStyle xmlns:a="http://schemas.openxmlformats.org/drawingml/2006/main"/>
-          <a:p xmlns:a="http://schemas.openxmlformats.org/drawingml/2006/main"/>
+          <a:p xmlns:a="http://schemas.openxmlformats.org/drawingml/2006/main">
+            <a:r>
+              <a:t>開場：這份簡報回答兩件事：程式碼是否具企業級思維，以及還缺哪些正式上線條件。</a:t>
+            </a:r>
+          </a:p>
+          <a:p xmlns:a="http://schemas.openxmlformats.org/drawingml/2006/main">
+            <a:r>
+              <a:t/>
+            </a:r>
+          </a:p>
+          <a:p xmlns:a="http://schemas.openxmlformats.org/drawingml/2006/main">
+            <a:r>
+              <a:t>[Sources]</a:t>
+            </a:r>
+          </a:p>
+          <a:p xmlns:a="http://schemas.openxmlformats.org/drawingml/2006/main">
+            <a:r>
+              <a:t>- Internal: docs/README.md</a:t>
+            </a:r>
+          </a:p>
+          <a:p xmlns:a="http://schemas.openxmlformats.org/drawingml/2006/main">
+            <a:r>
+              <a:t>- Internal: docs/01-管理摘要.md</a:t>
+            </a:r>
+          </a:p>
         </p:txBody>
       </p:sp>
       <p:sp>
@@ -610,7 +539,31 @@
         <p:txBody>
           <a:bodyPr xmlns:a="http://schemas.openxmlformats.org/drawingml/2006/main"/>
           <a:lstStyle xmlns:a="http://schemas.openxmlformats.org/drawingml/2006/main"/>
-          <a:p xmlns:a="http://schemas.openxmlformats.org/drawingml/2006/main"/>
+          <a:p xmlns:a="http://schemas.openxmlformats.org/drawingml/2006/main">
+            <a:r>
+              <a:t>建議核准環境建置，但正式上線必須以 P0 證據完成為前提。</a:t>
+            </a:r>
+          </a:p>
+          <a:p xmlns:a="http://schemas.openxmlformats.org/drawingml/2006/main">
+            <a:r>
+              <a:t/>
+            </a:r>
+          </a:p>
+          <a:p xmlns:a="http://schemas.openxmlformats.org/drawingml/2006/main">
+            <a:r>
+              <a:t>[Sources]</a:t>
+            </a:r>
+          </a:p>
+          <a:p xmlns:a="http://schemas.openxmlformats.org/drawingml/2006/main">
+            <a:r>
+              <a:t>- Internal: docs/01-管理摘要.md</a:t>
+            </a:r>
+          </a:p>
+          <a:p xmlns:a="http://schemas.openxmlformats.org/drawingml/2006/main">
+            <a:r>
+              <a:t>- Internal: docs/05-企業級成熟度與後續路線圖.md</a:t>
+            </a:r>
+          </a:p>
         </p:txBody>
       </p:sp>
       <p:sp>
@@ -676,7 +629,31 @@
         <p:txBody>
           <a:bodyPr xmlns:a="http://schemas.openxmlformats.org/drawingml/2006/main"/>
           <a:lstStyle xmlns:a="http://schemas.openxmlformats.org/drawingml/2006/main"/>
-          <a:p xmlns:a="http://schemas.openxmlformats.org/drawingml/2006/main"/>
+          <a:p xmlns:a="http://schemas.openxmlformats.org/drawingml/2006/main">
+            <a:r>
+              <a:t>結論要精準：本次完成的是程式碼與工程基線，不把尚未完成的正式環境驗收包裝成已認證。</a:t>
+            </a:r>
+          </a:p>
+          <a:p xmlns:a="http://schemas.openxmlformats.org/drawingml/2006/main">
+            <a:r>
+              <a:t/>
+            </a:r>
+          </a:p>
+          <a:p xmlns:a="http://schemas.openxmlformats.org/drawingml/2006/main">
+            <a:r>
+              <a:t>[Sources]</a:t>
+            </a:r>
+          </a:p>
+          <a:p xmlns:a="http://schemas.openxmlformats.org/drawingml/2006/main">
+            <a:r>
+              <a:t>- Internal: docs/01-管理摘要.md</a:t>
+            </a:r>
+          </a:p>
+          <a:p xmlns:a="http://schemas.openxmlformats.org/drawingml/2006/main">
+            <a:r>
+              <a:t>- Internal: docs/05-企業級成熟度與後續路線圖.md</a:t>
+            </a:r>
+          </a:p>
         </p:txBody>
       </p:sp>
       <p:sp>
@@ -742,7 +719,26 @@
         <p:txBody>
           <a:bodyPr xmlns:a="http://schemas.openxmlformats.org/drawingml/2006/main"/>
           <a:lstStyle xmlns:a="http://schemas.openxmlformats.org/drawingml/2006/main"/>
-          <a:p xmlns:a="http://schemas.openxmlformats.org/drawingml/2006/main"/>
+          <a:p xmlns:a="http://schemas.openxmlformats.org/drawingml/2006/main">
+            <a:r>
+              <a:t>架構依賴由自動化測試守門，前後端技術棧均維持專案既定選型。</a:t>
+            </a:r>
+          </a:p>
+          <a:p xmlns:a="http://schemas.openxmlformats.org/drawingml/2006/main">
+            <a:r>
+              <a:t/>
+            </a:r>
+          </a:p>
+          <a:p xmlns:a="http://schemas.openxmlformats.org/drawingml/2006/main">
+            <a:r>
+              <a:t>[Sources]</a:t>
+            </a:r>
+          </a:p>
+          <a:p xmlns:a="http://schemas.openxmlformats.org/drawingml/2006/main">
+            <a:r>
+              <a:t>- Internal: docs/02-系統與架構全覽.md</a:t>
+            </a:r>
+          </a:p>
         </p:txBody>
       </p:sp>
       <p:sp>
@@ -808,7 +804,26 @@
         <p:txBody>
           <a:bodyPr xmlns:a="http://schemas.openxmlformats.org/drawingml/2006/main"/>
           <a:lstStyle xmlns:a="http://schemas.openxmlformats.org/drawingml/2006/main"/>
-          <a:p xmlns:a="http://schemas.openxmlformats.org/drawingml/2006/main"/>
+          <a:p xmlns:a="http://schemas.openxmlformats.org/drawingml/2006/main">
+            <a:r>
+              <a:t>高風險控制均能對應測試或組態檢查，包含 Cookie、CSRF、refresh rotation、SignalR 與 Mongo 權限。</a:t>
+            </a:r>
+          </a:p>
+          <a:p xmlns:a="http://schemas.openxmlformats.org/drawingml/2006/main">
+            <a:r>
+              <a:t/>
+            </a:r>
+          </a:p>
+          <a:p xmlns:a="http://schemas.openxmlformats.org/drawingml/2006/main">
+            <a:r>
+              <a:t>[Sources]</a:t>
+            </a:r>
+          </a:p>
+          <a:p xmlns:a="http://schemas.openxmlformats.org/drawingml/2006/main">
+            <a:r>
+              <a:t>- Internal: docs/03-安全風險與修復台帳.md</a:t>
+            </a:r>
+          </a:p>
         </p:txBody>
       </p:sp>
       <p:sp>
@@ -874,7 +889,26 @@
         <p:txBody>
           <a:bodyPr xmlns:a="http://schemas.openxmlformats.org/drawingml/2006/main"/>
           <a:lstStyle xmlns:a="http://schemas.openxmlformats.org/drawingml/2006/main"/>
-          <a:p xmlns:a="http://schemas.openxmlformats.org/drawingml/2006/main"/>
+          <a:p xmlns:a="http://schemas.openxmlformats.org/drawingml/2006/main">
+            <a:r>
+              <a:t>工作階段安全採多層控制；Web Locks 避免多分頁同時 refresh 造成誤判。</a:t>
+            </a:r>
+          </a:p>
+          <a:p xmlns:a="http://schemas.openxmlformats.org/drawingml/2006/main">
+            <a:r>
+              <a:t/>
+            </a:r>
+          </a:p>
+          <a:p xmlns:a="http://schemas.openxmlformats.org/drawingml/2006/main">
+            <a:r>
+              <a:t>[Sources]</a:t>
+            </a:r>
+          </a:p>
+          <a:p xmlns:a="http://schemas.openxmlformats.org/drawingml/2006/main">
+            <a:r>
+              <a:t>- Internal: docs/03-安全風險與修復台帳.md</a:t>
+            </a:r>
+          </a:p>
         </p:txBody>
       </p:sp>
       <p:sp>
@@ -940,7 +974,41 @@
         <p:txBody>
           <a:bodyPr xmlns:a="http://schemas.openxmlformats.org/drawingml/2006/main"/>
           <a:lstStyle xmlns:a="http://schemas.openxmlformats.org/drawingml/2006/main"/>
-          <a:p xmlns:a="http://schemas.openxmlformats.org/drawingml/2006/main"/>
+          <a:p xmlns:a="http://schemas.openxmlformats.org/drawingml/2006/main">
+            <a:r>
+              <a:t>已清除 NuGet 已知漏洞；前端生產依賴沒有 High／Critical。正式 TLS 與 Secret Manager 仍屬環境責任。</a:t>
+            </a:r>
+          </a:p>
+          <a:p xmlns:a="http://schemas.openxmlformats.org/drawingml/2006/main">
+            <a:r>
+              <a:t/>
+            </a:r>
+          </a:p>
+          <a:p xmlns:a="http://schemas.openxmlformats.org/drawingml/2006/main">
+            <a:r>
+              <a:t>[Sources]</a:t>
+            </a:r>
+          </a:p>
+          <a:p xmlns:a="http://schemas.openxmlformats.org/drawingml/2006/main">
+            <a:r>
+              <a:t>- https://github.com/advisories/GHSA-v5pm-xwqc-g5wc</a:t>
+            </a:r>
+          </a:p>
+          <a:p xmlns:a="http://schemas.openxmlformats.org/drawingml/2006/main">
+            <a:r>
+              <a:t>- https://github.com/advisories/GHSA-pggp-6c3x-2xmx</a:t>
+            </a:r>
+          </a:p>
+          <a:p xmlns:a="http://schemas.openxmlformats.org/drawingml/2006/main">
+            <a:r>
+              <a:t>- https://github.com/advisories/GHSA-6c8g-7p36-r338</a:t>
+            </a:r>
+          </a:p>
+          <a:p xmlns:a="http://schemas.openxmlformats.org/drawingml/2006/main">
+            <a:r>
+              <a:t>- Internal: docs/04-部署與維運手冊.md</a:t>
+            </a:r>
+          </a:p>
         </p:txBody>
       </p:sp>
       <p:sp>
@@ -1006,7 +1074,36 @@
         <p:txBody>
           <a:bodyPr xmlns:a="http://schemas.openxmlformats.org/drawingml/2006/main"/>
           <a:lstStyle xmlns:a="http://schemas.openxmlformats.org/drawingml/2006/main"/>
-          <a:p xmlns:a="http://schemas.openxmlformats.org/drawingml/2006/main"/>
+          <a:p xmlns:a="http://schemas.openxmlformats.org/drawingml/2006/main">
+            <a:r>
+              <a:t>本機最終證據：後端 158/158、前端 54/54、ESLint 與 Next.js build 通過；CI 已加入同等閘門。</a:t>
+            </a:r>
+          </a:p>
+          <a:p xmlns:a="http://schemas.openxmlformats.org/drawingml/2006/main">
+            <a:r>
+              <a:t/>
+            </a:r>
+          </a:p>
+          <a:p xmlns:a="http://schemas.openxmlformats.org/drawingml/2006/main">
+            <a:r>
+              <a:t>[Sources]</a:t>
+            </a:r>
+          </a:p>
+          <a:p xmlns:a="http://schemas.openxmlformats.org/drawingml/2006/main">
+            <a:r>
+              <a:t>- https://learn.microsoft.com/dotnet/core/testing/microsoft-testing-platform-code-coverage</a:t>
+            </a:r>
+          </a:p>
+          <a:p xmlns:a="http://schemas.openxmlformats.org/drawingml/2006/main">
+            <a:r>
+              <a:t>- https://xunit.net/docs/getting-started/v3/microsoft-testing-platform</a:t>
+            </a:r>
+          </a:p>
+          <a:p xmlns:a="http://schemas.openxmlformats.org/drawingml/2006/main">
+            <a:r>
+              <a:t>- Internal: docs/07-Skills全面自檢報告.md</a:t>
+            </a:r>
+          </a:p>
         </p:txBody>
       </p:sp>
       <p:sp>
@@ -1072,7 +1169,31 @@
         <p:txBody>
           <a:bodyPr xmlns:a="http://schemas.openxmlformats.org/drawingml/2006/main"/>
           <a:lstStyle xmlns:a="http://schemas.openxmlformats.org/drawingml/2006/main"/>
-          <a:p xmlns:a="http://schemas.openxmlformats.org/drawingml/2006/main"/>
+          <a:p xmlns:a="http://schemas.openxmlformats.org/drawingml/2006/main">
+            <a:r>
+              <a:t>剩餘項目不是已知程式碼漏洞，而是必須在正式環境與組織制度中落地的控制。</a:t>
+            </a:r>
+          </a:p>
+          <a:p xmlns:a="http://schemas.openxmlformats.org/drawingml/2006/main">
+            <a:r>
+              <a:t/>
+            </a:r>
+          </a:p>
+          <a:p xmlns:a="http://schemas.openxmlformats.org/drawingml/2006/main">
+            <a:r>
+              <a:t>[Sources]</a:t>
+            </a:r>
+          </a:p>
+          <a:p xmlns:a="http://schemas.openxmlformats.org/drawingml/2006/main">
+            <a:r>
+              <a:t>- Internal: docs/03-安全風險與修復台帳.md</a:t>
+            </a:r>
+          </a:p>
+          <a:p xmlns:a="http://schemas.openxmlformats.org/drawingml/2006/main">
+            <a:r>
+              <a:t>- Internal: docs/05-企業級成熟度與後續路線圖.md</a:t>
+            </a:r>
+          </a:p>
         </p:txBody>
       </p:sp>
       <p:sp>
@@ -1138,7 +1259,26 @@
         <p:txBody>
           <a:bodyPr xmlns:a="http://schemas.openxmlformats.org/drawingml/2006/main"/>
           <a:lstStyle xmlns:a="http://schemas.openxmlformats.org/drawingml/2006/main"/>
-          <a:p xmlns:a="http://schemas.openxmlformats.org/drawingml/2006/main"/>
+          <a:p xmlns:a="http://schemas.openxmlformats.org/drawingml/2006/main">
+            <a:r>
+              <a:t>P0 是上線條件；P1 與 P2 將可運行系統提升為可持續治理的服務。</a:t>
+            </a:r>
+          </a:p>
+          <a:p xmlns:a="http://schemas.openxmlformats.org/drawingml/2006/main">
+            <a:r>
+              <a:t/>
+            </a:r>
+          </a:p>
+          <a:p xmlns:a="http://schemas.openxmlformats.org/drawingml/2006/main">
+            <a:r>
+              <a:t>[Sources]</a:t>
+            </a:r>
+          </a:p>
+          <a:p xmlns:a="http://schemas.openxmlformats.org/drawingml/2006/main">
+            <a:r>
+              <a:t>- Internal: docs/05-企業級成熟度與後續路線圖.md</a:t>
+            </a:r>
+          </a:p>
         </p:txBody>
       </p:sp>
       <p:sp>
@@ -1204,7 +1344,7 @@
   </p:cSld>
   <p:clrMap bg1="lt1" tx1="dk1" bg2="lt2" tx2="dk2" accent1="accent1" accent2="accent2" accent3="accent3" accent4="accent4" accent5="accent5" accent6="accent6" hlink="hlink" folHlink="folHlink"/>
   <p:sldLayoutIdLst>
-    <p:sldLayoutId xmlns:r="http://schemas.openxmlformats.org/officeDocument/2006/relationships" id="2147483649" r:id="R055e93d9224d4924"/>
+    <p:sldLayoutId xmlns:r="http://schemas.openxmlformats.org/officeDocument/2006/relationships" id="2147483649" r:id="R5fd227c515ae4455"/>
   </p:sldLayoutIdLst>
   <p:txStyles>
     <p:titleStyle>
@@ -1783,6 +1923,7 @@
           <a:lstStyle xmlns:a="http://schemas.openxmlformats.org/drawingml/2006/main"/>
           <a:p xmlns:a="http://schemas.openxmlformats.org/drawingml/2006/main">
             <a:pPr algn="l">
+              <a:buNone/>
               <a:defRPr sz="1200" b="1">
                 <a:solidFill>
                   <a:srgbClr val="3FB950"/>
@@ -1833,6 +1974,7 @@
           <a:lstStyle xmlns:a="http://schemas.openxmlformats.org/drawingml/2006/main"/>
           <a:p xmlns:a="http://schemas.openxmlformats.org/drawingml/2006/main">
             <a:pPr algn="l">
+              <a:buNone/>
               <a:defRPr sz="4800" b="1">
                 <a:solidFill>
                   <a:srgbClr val="FFFFFF"/>
@@ -1850,6 +1992,7 @@
           </a:p>
           <a:p xmlns:a="http://schemas.openxmlformats.org/drawingml/2006/main">
             <a:pPr algn="l">
+              <a:buNone/>
               <a:defRPr sz="4800" b="1">
                 <a:solidFill>
                   <a:srgbClr val="FFFFFF"/>
@@ -1900,6 +2043,7 @@
           <a:lstStyle xmlns:a="http://schemas.openxmlformats.org/drawingml/2006/main"/>
           <a:p xmlns:a="http://schemas.openxmlformats.org/drawingml/2006/main">
             <a:pPr algn="l">
+              <a:buNone/>
               <a:defRPr sz="1875" b="0">
                 <a:solidFill>
                   <a:srgbClr val="B1BAC4"/>
@@ -1981,6 +2125,7 @@
           <a:lstStyle xmlns:a="http://schemas.openxmlformats.org/drawingml/2006/main"/>
           <a:p xmlns:a="http://schemas.openxmlformats.org/drawingml/2006/main">
             <a:pPr algn="l">
+              <a:buNone/>
               <a:defRPr sz="1350" b="0">
                 <a:solidFill>
                   <a:srgbClr val="8C959F"/>
@@ -1993,7 +2138,7 @@
                   <a:srgbClr val="8C959F"/>
                 </a:solidFill>
               </a:rPr>
-              <a:t>管理簡報｜2026-07-24｜程式碼基準 d022e84</a:t>
+              <a:t>管理簡報｜2026-07-24｜完整本機驗證</a:t>
             </a:r>
           </a:p>
         </p:txBody>
@@ -2031,6 +2176,7 @@
           <a:lstStyle xmlns:a="http://schemas.openxmlformats.org/drawingml/2006/main"/>
           <a:p xmlns:a="http://schemas.openxmlformats.org/drawingml/2006/main">
             <a:pPr algn="l">
+              <a:buNone/>
               <a:defRPr sz="1050" b="0">
                 <a:solidFill>
                   <a:srgbClr val="8C959F"/>
@@ -2110,6 +2256,7 @@
           <a:lstStyle xmlns:a="http://schemas.openxmlformats.org/drawingml/2006/main"/>
           <a:p xmlns:a="http://schemas.openxmlformats.org/drawingml/2006/main">
             <a:pPr algn="l">
+              <a:buNone/>
               <a:defRPr sz="1050" b="1">
                 <a:solidFill>
                   <a:srgbClr val="1F883D"/>
@@ -2160,6 +2307,7 @@
           <a:lstStyle xmlns:a="http://schemas.openxmlformats.org/drawingml/2006/main"/>
           <a:p xmlns:a="http://schemas.openxmlformats.org/drawingml/2006/main">
             <a:pPr algn="l">
+              <a:buNone/>
               <a:defRPr sz="3600" b="1">
                 <a:solidFill>
                   <a:srgbClr val="0D1117"/>
@@ -2241,6 +2389,7 @@
           <a:lstStyle xmlns:a="http://schemas.openxmlformats.org/drawingml/2006/main"/>
           <a:p xmlns:a="http://schemas.openxmlformats.org/drawingml/2006/main">
             <a:pPr algn="l">
+              <a:buNone/>
               <a:defRPr sz="900" b="0">
                 <a:solidFill>
                   <a:srgbClr val="57606A"/>
@@ -2291,6 +2440,7 @@
           <a:lstStyle xmlns:a="http://schemas.openxmlformats.org/drawingml/2006/main"/>
           <a:p xmlns:a="http://schemas.openxmlformats.org/drawingml/2006/main">
             <a:pPr algn="r">
+              <a:buNone/>
               <a:defRPr sz="1050" b="1">
                 <a:solidFill>
                   <a:srgbClr val="57606A"/>
@@ -2374,6 +2524,7 @@
           <a:lstStyle xmlns:a="http://schemas.openxmlformats.org/drawingml/2006/main"/>
           <a:p xmlns:a="http://schemas.openxmlformats.org/drawingml/2006/main">
             <a:pPr algn="l">
+              <a:buNone/>
               <a:defRPr sz="1650" b="1">
                 <a:solidFill>
                   <a:srgbClr val="1F883D"/>
@@ -2424,6 +2575,7 @@
           <a:lstStyle xmlns:a="http://schemas.openxmlformats.org/drawingml/2006/main"/>
           <a:p xmlns:a="http://schemas.openxmlformats.org/drawingml/2006/main">
             <a:pPr algn="l">
+              <a:buNone/>
               <a:defRPr sz="2400" b="1">
                 <a:solidFill>
                   <a:srgbClr val="0D1117"/>
@@ -2441,6 +2593,7 @@
           </a:p>
           <a:p xmlns:a="http://schemas.openxmlformats.org/drawingml/2006/main">
             <a:pPr algn="l">
+              <a:buNone/>
               <a:defRPr sz="2400" b="1">
                 <a:solidFill>
                   <a:srgbClr val="0D1117"/>
@@ -2491,6 +2644,7 @@
           <a:lstStyle xmlns:a="http://schemas.openxmlformats.org/drawingml/2006/main"/>
           <a:p xmlns:a="http://schemas.openxmlformats.org/drawingml/2006/main">
             <a:pPr algn="l">
+              <a:buNone/>
               <a:defRPr sz="1500" b="1">
                 <a:solidFill>
                   <a:srgbClr val="57606A"/>
@@ -2541,6 +2695,7 @@
           <a:lstStyle xmlns:a="http://schemas.openxmlformats.org/drawingml/2006/main"/>
           <a:p xmlns:a="http://schemas.openxmlformats.org/drawingml/2006/main">
             <a:pPr algn="l">
+              <a:buNone/>
               <a:defRPr sz="1650" b="0">
                 <a:solidFill>
                   <a:srgbClr val="0D1117"/>
@@ -2553,7 +2708,7 @@
                   <a:srgbClr val="0D1117"/>
                 </a:solidFill>
               </a:rPr>
-              <a:t>•  程式碼層 Critical／High 風險已處理並由 CI 驗證</a:t>
+              <a:t>•  程式碼層 Critical／High 已處理，158＋54 項測試通過</a:t>
             </a:r>
           </a:p>
         </p:txBody>
@@ -2591,6 +2746,7 @@
           <a:lstStyle xmlns:a="http://schemas.openxmlformats.org/drawingml/2006/main"/>
           <a:p xmlns:a="http://schemas.openxmlformats.org/drawingml/2006/main">
             <a:pPr algn="l">
+              <a:buNone/>
               <a:defRPr sz="1650" b="0">
                 <a:solidFill>
                   <a:srgbClr val="0D1117"/>
@@ -2641,6 +2797,7 @@
           <a:lstStyle xmlns:a="http://schemas.openxmlformats.org/drawingml/2006/main"/>
           <a:p xmlns:a="http://schemas.openxmlformats.org/drawingml/2006/main">
             <a:pPr algn="l">
+              <a:buNone/>
               <a:defRPr sz="1650" b="0">
                 <a:solidFill>
                   <a:srgbClr val="1F883D"/>
@@ -2720,6 +2877,7 @@
           <a:lstStyle xmlns:a="http://schemas.openxmlformats.org/drawingml/2006/main"/>
           <a:p xmlns:a="http://schemas.openxmlformats.org/drawingml/2006/main">
             <a:pPr algn="l">
+              <a:buNone/>
               <a:defRPr sz="1050" b="1">
                 <a:solidFill>
                   <a:srgbClr val="1F883D"/>
@@ -2770,6 +2928,7 @@
           <a:lstStyle xmlns:a="http://schemas.openxmlformats.org/drawingml/2006/main"/>
           <a:p xmlns:a="http://schemas.openxmlformats.org/drawingml/2006/main">
             <a:pPr algn="l">
+              <a:buNone/>
               <a:defRPr sz="3600" b="1">
                 <a:solidFill>
                   <a:srgbClr val="0D1117"/>
@@ -2851,6 +3010,7 @@
           <a:lstStyle xmlns:a="http://schemas.openxmlformats.org/drawingml/2006/main"/>
           <a:p xmlns:a="http://schemas.openxmlformats.org/drawingml/2006/main">
             <a:pPr algn="l">
+              <a:buNone/>
               <a:defRPr sz="900" b="0">
                 <a:solidFill>
                   <a:srgbClr val="57606A"/>
@@ -2901,6 +3061,7 @@
           <a:lstStyle xmlns:a="http://schemas.openxmlformats.org/drawingml/2006/main"/>
           <a:p xmlns:a="http://schemas.openxmlformats.org/drawingml/2006/main">
             <a:pPr algn="r">
+              <a:buNone/>
               <a:defRPr sz="1050" b="1">
                 <a:solidFill>
                   <a:srgbClr val="57606A"/>
@@ -2984,6 +3145,7 @@
           <a:lstStyle xmlns:a="http://schemas.openxmlformats.org/drawingml/2006/main"/>
           <a:p xmlns:a="http://schemas.openxmlformats.org/drawingml/2006/main">
             <a:pPr algn="l">
+              <a:buNone/>
               <a:defRPr sz="2250" b="1">
                 <a:solidFill>
                   <a:srgbClr val="0D1117"/>
@@ -3001,6 +3163,7 @@
           </a:p>
           <a:p xmlns:a="http://schemas.openxmlformats.org/drawingml/2006/main">
             <a:pPr algn="l">
+              <a:buNone/>
               <a:defRPr sz="2250" b="1">
                 <a:solidFill>
                   <a:srgbClr val="0D1117"/>
@@ -3084,6 +3247,7 @@
           <a:lstStyle xmlns:a="http://schemas.openxmlformats.org/drawingml/2006/main"/>
           <a:p xmlns:a="http://schemas.openxmlformats.org/drawingml/2006/main">
             <a:pPr algn="l">
+              <a:buNone/>
               <a:defRPr sz="3300" b="1">
                 <a:solidFill>
                   <a:srgbClr val="1F883D"/>
@@ -3134,6 +3298,7 @@
           <a:lstStyle xmlns:a="http://schemas.openxmlformats.org/drawingml/2006/main"/>
           <a:p xmlns:a="http://schemas.openxmlformats.org/drawingml/2006/main">
             <a:pPr algn="l">
+              <a:buNone/>
               <a:defRPr sz="1350" b="1">
                 <a:solidFill>
                   <a:srgbClr val="57606A"/>
@@ -3217,6 +3382,7 @@
           <a:lstStyle xmlns:a="http://schemas.openxmlformats.org/drawingml/2006/main"/>
           <a:p xmlns:a="http://schemas.openxmlformats.org/drawingml/2006/main">
             <a:pPr algn="l">
+              <a:buNone/>
               <a:defRPr sz="3300" b="1">
                 <a:solidFill>
                   <a:srgbClr val="0969DA"/>
@@ -3267,6 +3433,7 @@
           <a:lstStyle xmlns:a="http://schemas.openxmlformats.org/drawingml/2006/main"/>
           <a:p xmlns:a="http://schemas.openxmlformats.org/drawingml/2006/main">
             <a:pPr algn="l">
+              <a:buNone/>
               <a:defRPr sz="1350" b="1">
                 <a:solidFill>
                   <a:srgbClr val="57606A"/>
@@ -3350,6 +3517,7 @@
           <a:lstStyle xmlns:a="http://schemas.openxmlformats.org/drawingml/2006/main"/>
           <a:p xmlns:a="http://schemas.openxmlformats.org/drawingml/2006/main">
             <a:pPr algn="l">
+              <a:buNone/>
               <a:defRPr sz="3300" b="1">
                 <a:solidFill>
                   <a:srgbClr val="BF8700"/>
@@ -3400,6 +3568,7 @@
           <a:lstStyle xmlns:a="http://schemas.openxmlformats.org/drawingml/2006/main"/>
           <a:p xmlns:a="http://schemas.openxmlformats.org/drawingml/2006/main">
             <a:pPr algn="l">
+              <a:buNone/>
               <a:defRPr sz="1350" b="1">
                 <a:solidFill>
                   <a:srgbClr val="57606A"/>
@@ -3450,6 +3619,7 @@
           <a:lstStyle xmlns:a="http://schemas.openxmlformats.org/drawingml/2006/main"/>
           <a:p xmlns:a="http://schemas.openxmlformats.org/drawingml/2006/main">
             <a:pPr algn="l">
+              <a:buNone/>
               <a:defRPr sz="1800" b="1">
                 <a:solidFill>
                   <a:srgbClr val="0D1117"/>
@@ -3462,7 +3632,7 @@
                   <a:srgbClr val="0D1117"/>
                 </a:solidFill>
               </a:rPr>
-              <a:t>管理意義：不需要重寫技術棧；下一階段投資應放在 TLS、秘密管理、監控、備援與治理。</a:t>
+              <a:t>管理意義：不需重寫技術棧；正式上線投資聚焦 TLS、秘密管理、監控、備援與治理。</a:t>
             </a:r>
           </a:p>
         </p:txBody>
@@ -3529,6 +3699,7 @@
           <a:lstStyle xmlns:a="http://schemas.openxmlformats.org/drawingml/2006/main"/>
           <a:p xmlns:a="http://schemas.openxmlformats.org/drawingml/2006/main">
             <a:pPr algn="l">
+              <a:buNone/>
               <a:defRPr sz="1050" b="1">
                 <a:solidFill>
                   <a:srgbClr val="1F883D"/>
@@ -3579,6 +3750,7 @@
           <a:lstStyle xmlns:a="http://schemas.openxmlformats.org/drawingml/2006/main"/>
           <a:p xmlns:a="http://schemas.openxmlformats.org/drawingml/2006/main">
             <a:pPr algn="l">
+              <a:buNone/>
               <a:defRPr sz="3600" b="1">
                 <a:solidFill>
                   <a:srgbClr val="0D1117"/>
@@ -3660,6 +3832,7 @@
           <a:lstStyle xmlns:a="http://schemas.openxmlformats.org/drawingml/2006/main"/>
           <a:p xmlns:a="http://schemas.openxmlformats.org/drawingml/2006/main">
             <a:pPr algn="l">
+              <a:buNone/>
               <a:defRPr sz="900" b="0">
                 <a:solidFill>
                   <a:srgbClr val="57606A"/>
@@ -3710,6 +3883,7 @@
           <a:lstStyle xmlns:a="http://schemas.openxmlformats.org/drawingml/2006/main"/>
           <a:p xmlns:a="http://schemas.openxmlformats.org/drawingml/2006/main">
             <a:pPr algn="r">
+              <a:buNone/>
               <a:defRPr sz="1050" b="1">
                 <a:solidFill>
                   <a:srgbClr val="57606A"/>
@@ -3793,6 +3967,7 @@
           <a:lstStyle xmlns:a="http://schemas.openxmlformats.org/drawingml/2006/main"/>
           <a:p xmlns:a="http://schemas.openxmlformats.org/drawingml/2006/main">
             <a:pPr algn="l">
+              <a:buNone/>
               <a:defRPr sz="2025" b="1">
                 <a:solidFill>
                   <a:srgbClr val="0D1117"/>
@@ -3843,6 +4018,7 @@
           <a:lstStyle xmlns:a="http://schemas.openxmlformats.org/drawingml/2006/main"/>
           <a:p xmlns:a="http://schemas.openxmlformats.org/drawingml/2006/main">
             <a:pPr algn="l">
+              <a:buNone/>
               <a:defRPr sz="1350" b="0">
                 <a:solidFill>
                   <a:srgbClr val="57606A"/>
@@ -3926,6 +4102,7 @@
           <a:lstStyle xmlns:a="http://schemas.openxmlformats.org/drawingml/2006/main"/>
           <a:p xmlns:a="http://schemas.openxmlformats.org/drawingml/2006/main">
             <a:pPr algn="l">
+              <a:buNone/>
               <a:defRPr sz="2025" b="1">
                 <a:solidFill>
                   <a:srgbClr val="0D1117"/>
@@ -3976,6 +4153,7 @@
           <a:lstStyle xmlns:a="http://schemas.openxmlformats.org/drawingml/2006/main"/>
           <a:p xmlns:a="http://schemas.openxmlformats.org/drawingml/2006/main">
             <a:pPr algn="l">
+              <a:buNone/>
               <a:defRPr sz="1350" b="0">
                 <a:solidFill>
                   <a:srgbClr val="57606A"/>
@@ -4059,6 +4237,7 @@
           <a:lstStyle xmlns:a="http://schemas.openxmlformats.org/drawingml/2006/main"/>
           <a:p xmlns:a="http://schemas.openxmlformats.org/drawingml/2006/main">
             <a:pPr algn="l">
+              <a:buNone/>
               <a:defRPr sz="2025" b="1">
                 <a:solidFill>
                   <a:srgbClr val="0D1117"/>
@@ -4109,6 +4288,7 @@
           <a:lstStyle xmlns:a="http://schemas.openxmlformats.org/drawingml/2006/main"/>
           <a:p xmlns:a="http://schemas.openxmlformats.org/drawingml/2006/main">
             <a:pPr algn="l">
+              <a:buNone/>
               <a:defRPr sz="1350" b="0">
                 <a:solidFill>
                   <a:srgbClr val="57606A"/>
@@ -4192,6 +4372,7 @@
           <a:lstStyle xmlns:a="http://schemas.openxmlformats.org/drawingml/2006/main"/>
           <a:p xmlns:a="http://schemas.openxmlformats.org/drawingml/2006/main">
             <a:pPr algn="l">
+              <a:buNone/>
               <a:defRPr sz="2025" b="1">
                 <a:solidFill>
                   <a:srgbClr val="0D1117"/>
@@ -4242,6 +4423,7 @@
           <a:lstStyle xmlns:a="http://schemas.openxmlformats.org/drawingml/2006/main"/>
           <a:p xmlns:a="http://schemas.openxmlformats.org/drawingml/2006/main">
             <a:pPr algn="l">
+              <a:buNone/>
               <a:defRPr sz="1350" b="0">
                 <a:solidFill>
                   <a:srgbClr val="57606A"/>
@@ -4325,6 +4507,7 @@
           <a:lstStyle xmlns:a="http://schemas.openxmlformats.org/drawingml/2006/main"/>
           <a:p xmlns:a="http://schemas.openxmlformats.org/drawingml/2006/main">
             <a:pPr algn="l">
+              <a:buNone/>
               <a:defRPr sz="2025" b="1">
                 <a:solidFill>
                   <a:srgbClr val="0D1117"/>
@@ -4375,6 +4558,7 @@
           <a:lstStyle xmlns:a="http://schemas.openxmlformats.org/drawingml/2006/main"/>
           <a:p xmlns:a="http://schemas.openxmlformats.org/drawingml/2006/main">
             <a:pPr algn="l">
+              <a:buNone/>
               <a:defRPr sz="1350" b="0">
                 <a:solidFill>
                   <a:srgbClr val="57606A"/>
@@ -4458,6 +4642,7 @@
           <a:lstStyle xmlns:a="http://schemas.openxmlformats.org/drawingml/2006/main"/>
           <a:p xmlns:a="http://schemas.openxmlformats.org/drawingml/2006/main">
             <a:pPr algn="l">
+              <a:buNone/>
               <a:defRPr sz="2025" b="1">
                 <a:solidFill>
                   <a:srgbClr val="0D1117"/>
@@ -4508,6 +4693,7 @@
           <a:lstStyle xmlns:a="http://schemas.openxmlformats.org/drawingml/2006/main"/>
           <a:p xmlns:a="http://schemas.openxmlformats.org/drawingml/2006/main">
             <a:pPr algn="l">
+              <a:buNone/>
               <a:defRPr sz="1350" b="0">
                 <a:solidFill>
                   <a:srgbClr val="57606A"/>
@@ -4558,6 +4744,7 @@
           <a:lstStyle xmlns:a="http://schemas.openxmlformats.org/drawingml/2006/main"/>
           <a:p xmlns:a="http://schemas.openxmlformats.org/drawingml/2006/main">
             <a:pPr algn="l">
+              <a:buNone/>
               <a:defRPr sz="1575" b="1">
                 <a:solidFill>
                   <a:srgbClr val="1F883D"/>
@@ -4637,6 +4824,7 @@
           <a:lstStyle xmlns:a="http://schemas.openxmlformats.org/drawingml/2006/main"/>
           <a:p xmlns:a="http://schemas.openxmlformats.org/drawingml/2006/main">
             <a:pPr algn="l">
+              <a:buNone/>
               <a:defRPr sz="1050" b="1">
                 <a:solidFill>
                   <a:srgbClr val="1F883D"/>
@@ -4687,6 +4875,7 @@
           <a:lstStyle xmlns:a="http://schemas.openxmlformats.org/drawingml/2006/main"/>
           <a:p xmlns:a="http://schemas.openxmlformats.org/drawingml/2006/main">
             <a:pPr algn="l">
+              <a:buNone/>
               <a:defRPr sz="3600" b="1">
                 <a:solidFill>
                   <a:srgbClr val="0D1117"/>
@@ -4768,6 +4957,7 @@
           <a:lstStyle xmlns:a="http://schemas.openxmlformats.org/drawingml/2006/main"/>
           <a:p xmlns:a="http://schemas.openxmlformats.org/drawingml/2006/main">
             <a:pPr algn="l">
+              <a:buNone/>
               <a:defRPr sz="900" b="0">
                 <a:solidFill>
                   <a:srgbClr val="57606A"/>
@@ -4818,6 +5008,7 @@
           <a:lstStyle xmlns:a="http://schemas.openxmlformats.org/drawingml/2006/main"/>
           <a:p xmlns:a="http://schemas.openxmlformats.org/drawingml/2006/main">
             <a:pPr algn="r">
+              <a:buNone/>
               <a:defRPr sz="1050" b="1">
                 <a:solidFill>
                   <a:srgbClr val="57606A"/>
@@ -4868,6 +5059,7 @@
           <a:lstStyle xmlns:a="http://schemas.openxmlformats.org/drawingml/2006/main"/>
           <a:p xmlns:a="http://schemas.openxmlformats.org/drawingml/2006/main">
             <a:pPr algn="l">
+              <a:buNone/>
               <a:defRPr sz="1500" b="1">
                 <a:solidFill>
                   <a:srgbClr val="CF222E"/>
@@ -4918,6 +5110,7 @@
           <a:lstStyle xmlns:a="http://schemas.openxmlformats.org/drawingml/2006/main"/>
           <a:p xmlns:a="http://schemas.openxmlformats.org/drawingml/2006/main">
             <a:pPr algn="l">
+              <a:buNone/>
               <a:defRPr sz="1500" b="1">
                 <a:solidFill>
                   <a:srgbClr val="1F883D"/>
@@ -4968,6 +5161,7 @@
           <a:lstStyle xmlns:a="http://schemas.openxmlformats.org/drawingml/2006/main"/>
           <a:p xmlns:a="http://schemas.openxmlformats.org/drawingml/2006/main">
             <a:pPr algn="l">
+              <a:buNone/>
               <a:defRPr sz="1575" b="0">
                 <a:solidFill>
                   <a:srgbClr val="0D1117"/>
@@ -5018,6 +5212,7 @@
           <a:lstStyle xmlns:a="http://schemas.openxmlformats.org/drawingml/2006/main"/>
           <a:p xmlns:a="http://schemas.openxmlformats.org/drawingml/2006/main">
             <a:pPr algn="ctr">
+              <a:buNone/>
               <a:defRPr sz="1800" b="1">
                 <a:solidFill>
                   <a:srgbClr val="57606A"/>
@@ -5068,6 +5263,7 @@
           <a:lstStyle xmlns:a="http://schemas.openxmlformats.org/drawingml/2006/main"/>
           <a:p xmlns:a="http://schemas.openxmlformats.org/drawingml/2006/main">
             <a:pPr algn="l">
+              <a:buNone/>
               <a:defRPr sz="1575" b="1">
                 <a:solidFill>
                   <a:srgbClr val="0D1117"/>
@@ -5149,6 +5345,7 @@
           <a:lstStyle xmlns:a="http://schemas.openxmlformats.org/drawingml/2006/main"/>
           <a:p xmlns:a="http://schemas.openxmlformats.org/drawingml/2006/main">
             <a:pPr algn="l">
+              <a:buNone/>
               <a:defRPr sz="1575" b="0">
                 <a:solidFill>
                   <a:srgbClr val="0D1117"/>
@@ -5199,6 +5396,7 @@
           <a:lstStyle xmlns:a="http://schemas.openxmlformats.org/drawingml/2006/main"/>
           <a:p xmlns:a="http://schemas.openxmlformats.org/drawingml/2006/main">
             <a:pPr algn="ctr">
+              <a:buNone/>
               <a:defRPr sz="1800" b="1">
                 <a:solidFill>
                   <a:srgbClr val="57606A"/>
@@ -5249,6 +5447,7 @@
           <a:lstStyle xmlns:a="http://schemas.openxmlformats.org/drawingml/2006/main"/>
           <a:p xmlns:a="http://schemas.openxmlformats.org/drawingml/2006/main">
             <a:pPr algn="l">
+              <a:buNone/>
               <a:defRPr sz="1575" b="1">
                 <a:solidFill>
                   <a:srgbClr val="0D1117"/>
@@ -5330,6 +5529,7 @@
           <a:lstStyle xmlns:a="http://schemas.openxmlformats.org/drawingml/2006/main"/>
           <a:p xmlns:a="http://schemas.openxmlformats.org/drawingml/2006/main">
             <a:pPr algn="l">
+              <a:buNone/>
               <a:defRPr sz="1575" b="0">
                 <a:solidFill>
                   <a:srgbClr val="0D1117"/>
@@ -5380,6 +5580,7 @@
           <a:lstStyle xmlns:a="http://schemas.openxmlformats.org/drawingml/2006/main"/>
           <a:p xmlns:a="http://schemas.openxmlformats.org/drawingml/2006/main">
             <a:pPr algn="ctr">
+              <a:buNone/>
               <a:defRPr sz="1800" b="1">
                 <a:solidFill>
                   <a:srgbClr val="57606A"/>
@@ -5430,6 +5631,7 @@
           <a:lstStyle xmlns:a="http://schemas.openxmlformats.org/drawingml/2006/main"/>
           <a:p xmlns:a="http://schemas.openxmlformats.org/drawingml/2006/main">
             <a:pPr algn="l">
+              <a:buNone/>
               <a:defRPr sz="1575" b="1">
                 <a:solidFill>
                   <a:srgbClr val="0D1117"/>
@@ -5511,6 +5713,7 @@
           <a:lstStyle xmlns:a="http://schemas.openxmlformats.org/drawingml/2006/main"/>
           <a:p xmlns:a="http://schemas.openxmlformats.org/drawingml/2006/main">
             <a:pPr algn="l">
+              <a:buNone/>
               <a:defRPr sz="1575" b="0">
                 <a:solidFill>
                   <a:srgbClr val="0D1117"/>
@@ -5561,6 +5764,7 @@
           <a:lstStyle xmlns:a="http://schemas.openxmlformats.org/drawingml/2006/main"/>
           <a:p xmlns:a="http://schemas.openxmlformats.org/drawingml/2006/main">
             <a:pPr algn="ctr">
+              <a:buNone/>
               <a:defRPr sz="1800" b="1">
                 <a:solidFill>
                   <a:srgbClr val="57606A"/>
@@ -5611,6 +5815,7 @@
           <a:lstStyle xmlns:a="http://schemas.openxmlformats.org/drawingml/2006/main"/>
           <a:p xmlns:a="http://schemas.openxmlformats.org/drawingml/2006/main">
             <a:pPr algn="l">
+              <a:buNone/>
               <a:defRPr sz="1575" b="1">
                 <a:solidFill>
                   <a:srgbClr val="0D1117"/>
@@ -5692,6 +5897,7 @@
           <a:lstStyle xmlns:a="http://schemas.openxmlformats.org/drawingml/2006/main"/>
           <a:p xmlns:a="http://schemas.openxmlformats.org/drawingml/2006/main">
             <a:pPr algn="l">
+              <a:buNone/>
               <a:defRPr sz="1575" b="0">
                 <a:solidFill>
                   <a:srgbClr val="0D1117"/>
@@ -5742,6 +5948,7 @@
           <a:lstStyle xmlns:a="http://schemas.openxmlformats.org/drawingml/2006/main"/>
           <a:p xmlns:a="http://schemas.openxmlformats.org/drawingml/2006/main">
             <a:pPr algn="ctr">
+              <a:buNone/>
               <a:defRPr sz="1800" b="1">
                 <a:solidFill>
                   <a:srgbClr val="57606A"/>
@@ -5792,6 +5999,7 @@
           <a:lstStyle xmlns:a="http://schemas.openxmlformats.org/drawingml/2006/main"/>
           <a:p xmlns:a="http://schemas.openxmlformats.org/drawingml/2006/main">
             <a:pPr algn="l">
+              <a:buNone/>
               <a:defRPr sz="1575" b="1">
                 <a:solidFill>
                   <a:srgbClr val="0D1117"/>
@@ -5873,6 +6081,7 @@
           <a:lstStyle xmlns:a="http://schemas.openxmlformats.org/drawingml/2006/main"/>
           <a:p xmlns:a="http://schemas.openxmlformats.org/drawingml/2006/main">
             <a:pPr algn="l">
+              <a:buNone/>
               <a:defRPr sz="1575" b="0">
                 <a:solidFill>
                   <a:srgbClr val="0D1117"/>
@@ -5923,6 +6132,7 @@
           <a:lstStyle xmlns:a="http://schemas.openxmlformats.org/drawingml/2006/main"/>
           <a:p xmlns:a="http://schemas.openxmlformats.org/drawingml/2006/main">
             <a:pPr algn="ctr">
+              <a:buNone/>
               <a:defRPr sz="1800" b="1">
                 <a:solidFill>
                   <a:srgbClr val="57606A"/>
@@ -5973,6 +6183,7 @@
           <a:lstStyle xmlns:a="http://schemas.openxmlformats.org/drawingml/2006/main"/>
           <a:p xmlns:a="http://schemas.openxmlformats.org/drawingml/2006/main">
             <a:pPr algn="l">
+              <a:buNone/>
               <a:defRPr sz="1575" b="1">
                 <a:solidFill>
                   <a:srgbClr val="0D1117"/>
@@ -6052,6 +6263,7 @@
           <a:lstStyle xmlns:a="http://schemas.openxmlformats.org/drawingml/2006/main"/>
           <a:p xmlns:a="http://schemas.openxmlformats.org/drawingml/2006/main">
             <a:pPr algn="l">
+              <a:buNone/>
               <a:defRPr sz="1050" b="1">
                 <a:solidFill>
                   <a:srgbClr val="1F883D"/>
@@ -6102,6 +6314,7 @@
           <a:lstStyle xmlns:a="http://schemas.openxmlformats.org/drawingml/2006/main"/>
           <a:p xmlns:a="http://schemas.openxmlformats.org/drawingml/2006/main">
             <a:pPr algn="l">
+              <a:buNone/>
               <a:defRPr sz="3600" b="1">
                 <a:solidFill>
                   <a:srgbClr val="0D1117"/>
@@ -6183,6 +6396,7 @@
           <a:lstStyle xmlns:a="http://schemas.openxmlformats.org/drawingml/2006/main"/>
           <a:p xmlns:a="http://schemas.openxmlformats.org/drawingml/2006/main">
             <a:pPr algn="l">
+              <a:buNone/>
               <a:defRPr sz="900" b="0">
                 <a:solidFill>
                   <a:srgbClr val="57606A"/>
@@ -6233,6 +6447,7 @@
           <a:lstStyle xmlns:a="http://schemas.openxmlformats.org/drawingml/2006/main"/>
           <a:p xmlns:a="http://schemas.openxmlformats.org/drawingml/2006/main">
             <a:pPr algn="r">
+              <a:buNone/>
               <a:defRPr sz="1050" b="1">
                 <a:solidFill>
                   <a:srgbClr val="57606A"/>
@@ -6316,6 +6531,7 @@
           <a:lstStyle xmlns:a="http://schemas.openxmlformats.org/drawingml/2006/main"/>
           <a:p xmlns:a="http://schemas.openxmlformats.org/drawingml/2006/main">
             <a:pPr algn="l">
+              <a:buNone/>
               <a:defRPr sz="2400" b="1">
                 <a:solidFill>
                   <a:srgbClr val="1F883D"/>
@@ -6366,6 +6582,7 @@
           <a:lstStyle xmlns:a="http://schemas.openxmlformats.org/drawingml/2006/main"/>
           <a:p xmlns:a="http://schemas.openxmlformats.org/drawingml/2006/main">
             <a:pPr algn="l">
+              <a:buNone/>
               <a:defRPr sz="1800" b="1">
                 <a:solidFill>
                   <a:srgbClr val="0D1117"/>
@@ -6416,6 +6633,7 @@
           <a:lstStyle xmlns:a="http://schemas.openxmlformats.org/drawingml/2006/main"/>
           <a:p xmlns:a="http://schemas.openxmlformats.org/drawingml/2006/main">
             <a:pPr algn="l">
+              <a:buNone/>
               <a:defRPr sz="1350" b="0">
                 <a:solidFill>
                   <a:srgbClr val="57606A"/>
@@ -6499,6 +6717,7 @@
           <a:lstStyle xmlns:a="http://schemas.openxmlformats.org/drawingml/2006/main"/>
           <a:p xmlns:a="http://schemas.openxmlformats.org/drawingml/2006/main">
             <a:pPr algn="l">
+              <a:buNone/>
               <a:defRPr sz="2400" b="1">
                 <a:solidFill>
                   <a:srgbClr val="1F883D"/>
@@ -6549,6 +6768,7 @@
           <a:lstStyle xmlns:a="http://schemas.openxmlformats.org/drawingml/2006/main"/>
           <a:p xmlns:a="http://schemas.openxmlformats.org/drawingml/2006/main">
             <a:pPr algn="l">
+              <a:buNone/>
               <a:defRPr sz="1800" b="1">
                 <a:solidFill>
                   <a:srgbClr val="0D1117"/>
@@ -6599,6 +6819,7 @@
           <a:lstStyle xmlns:a="http://schemas.openxmlformats.org/drawingml/2006/main"/>
           <a:p xmlns:a="http://schemas.openxmlformats.org/drawingml/2006/main">
             <a:pPr algn="l">
+              <a:buNone/>
               <a:defRPr sz="1350" b="0">
                 <a:solidFill>
                   <a:srgbClr val="57606A"/>
@@ -6682,6 +6903,7 @@
           <a:lstStyle xmlns:a="http://schemas.openxmlformats.org/drawingml/2006/main"/>
           <a:p xmlns:a="http://schemas.openxmlformats.org/drawingml/2006/main">
             <a:pPr algn="l">
+              <a:buNone/>
               <a:defRPr sz="2400" b="1">
                 <a:solidFill>
                   <a:srgbClr val="1F883D"/>
@@ -6732,6 +6954,7 @@
           <a:lstStyle xmlns:a="http://schemas.openxmlformats.org/drawingml/2006/main"/>
           <a:p xmlns:a="http://schemas.openxmlformats.org/drawingml/2006/main">
             <a:pPr algn="l">
+              <a:buNone/>
               <a:defRPr sz="1800" b="1">
                 <a:solidFill>
                   <a:srgbClr val="0D1117"/>
@@ -6782,6 +7005,7 @@
           <a:lstStyle xmlns:a="http://schemas.openxmlformats.org/drawingml/2006/main"/>
           <a:p xmlns:a="http://schemas.openxmlformats.org/drawingml/2006/main">
             <a:pPr algn="l">
+              <a:buNone/>
               <a:defRPr sz="1350" b="0">
                 <a:solidFill>
                   <a:srgbClr val="57606A"/>
@@ -6865,6 +7089,7 @@
           <a:lstStyle xmlns:a="http://schemas.openxmlformats.org/drawingml/2006/main"/>
           <a:p xmlns:a="http://schemas.openxmlformats.org/drawingml/2006/main">
             <a:pPr algn="l">
+              <a:buNone/>
               <a:defRPr sz="2400" b="1">
                 <a:solidFill>
                   <a:srgbClr val="1F883D"/>
@@ -6915,6 +7140,7 @@
           <a:lstStyle xmlns:a="http://schemas.openxmlformats.org/drawingml/2006/main"/>
           <a:p xmlns:a="http://schemas.openxmlformats.org/drawingml/2006/main">
             <a:pPr algn="l">
+              <a:buNone/>
               <a:defRPr sz="1800" b="1">
                 <a:solidFill>
                   <a:srgbClr val="0D1117"/>
@@ -6965,6 +7191,7 @@
           <a:lstStyle xmlns:a="http://schemas.openxmlformats.org/drawingml/2006/main"/>
           <a:p xmlns:a="http://schemas.openxmlformats.org/drawingml/2006/main">
             <a:pPr algn="l">
+              <a:buNone/>
               <a:defRPr sz="1350" b="0">
                 <a:solidFill>
                   <a:srgbClr val="57606A"/>
@@ -7048,6 +7275,7 @@
           <a:lstStyle xmlns:a="http://schemas.openxmlformats.org/drawingml/2006/main"/>
           <a:p xmlns:a="http://schemas.openxmlformats.org/drawingml/2006/main">
             <a:pPr algn="l">
+              <a:buNone/>
               <a:defRPr sz="2400" b="1">
                 <a:solidFill>
                   <a:srgbClr val="BF8700"/>
@@ -7098,6 +7326,7 @@
           <a:lstStyle xmlns:a="http://schemas.openxmlformats.org/drawingml/2006/main"/>
           <a:p xmlns:a="http://schemas.openxmlformats.org/drawingml/2006/main">
             <a:pPr algn="l">
+              <a:buNone/>
               <a:defRPr sz="1800" b="1">
                 <a:solidFill>
                   <a:srgbClr val="0D1117"/>
@@ -7148,6 +7377,7 @@
           <a:lstStyle xmlns:a="http://schemas.openxmlformats.org/drawingml/2006/main"/>
           <a:p xmlns:a="http://schemas.openxmlformats.org/drawingml/2006/main">
             <a:pPr algn="l">
+              <a:buNone/>
               <a:defRPr sz="1350" b="0">
                 <a:solidFill>
                   <a:srgbClr val="57606A"/>
@@ -7198,6 +7428,7 @@
           <a:lstStyle xmlns:a="http://schemas.openxmlformats.org/drawingml/2006/main"/>
           <a:p xmlns:a="http://schemas.openxmlformats.org/drawingml/2006/main">
             <a:pPr algn="l">
+              <a:buNone/>
               <a:defRPr sz="1875" b="1">
                 <a:solidFill>
                   <a:srgbClr val="0969DA"/>
@@ -7277,6 +7508,7 @@
           <a:lstStyle xmlns:a="http://schemas.openxmlformats.org/drawingml/2006/main"/>
           <a:p xmlns:a="http://schemas.openxmlformats.org/drawingml/2006/main">
             <a:pPr algn="l">
+              <a:buNone/>
               <a:defRPr sz="1050" b="1">
                 <a:solidFill>
                   <a:srgbClr val="1F883D"/>
@@ -7327,6 +7559,7 @@
           <a:lstStyle xmlns:a="http://schemas.openxmlformats.org/drawingml/2006/main"/>
           <a:p xmlns:a="http://schemas.openxmlformats.org/drawingml/2006/main">
             <a:pPr algn="l">
+              <a:buNone/>
               <a:defRPr sz="3600" b="1">
                 <a:solidFill>
                   <a:srgbClr val="0D1117"/>
@@ -7408,6 +7641,7 @@
           <a:lstStyle xmlns:a="http://schemas.openxmlformats.org/drawingml/2006/main"/>
           <a:p xmlns:a="http://schemas.openxmlformats.org/drawingml/2006/main">
             <a:pPr algn="l">
+              <a:buNone/>
               <a:defRPr sz="900" b="0">
                 <a:solidFill>
                   <a:srgbClr val="57606A"/>
@@ -7458,6 +7692,7 @@
           <a:lstStyle xmlns:a="http://schemas.openxmlformats.org/drawingml/2006/main"/>
           <a:p xmlns:a="http://schemas.openxmlformats.org/drawingml/2006/main">
             <a:pPr algn="r">
+              <a:buNone/>
               <a:defRPr sz="1050" b="1">
                 <a:solidFill>
                   <a:srgbClr val="57606A"/>
@@ -7541,6 +7776,7 @@
           <a:lstStyle xmlns:a="http://schemas.openxmlformats.org/drawingml/2006/main"/>
           <a:p xmlns:a="http://schemas.openxmlformats.org/drawingml/2006/main">
             <a:pPr algn="l">
+              <a:buNone/>
               <a:defRPr sz="1725" b="1">
                 <a:solidFill>
                   <a:srgbClr val="0D1117"/>
@@ -7591,6 +7827,7 @@
           <a:lstStyle xmlns:a="http://schemas.openxmlformats.org/drawingml/2006/main"/>
           <a:p xmlns:a="http://schemas.openxmlformats.org/drawingml/2006/main">
             <a:pPr algn="l">
+              <a:buNone/>
               <a:defRPr sz="1350" b="0">
                 <a:solidFill>
                   <a:srgbClr val="57606A"/>
@@ -7674,6 +7911,7 @@
           <a:lstStyle xmlns:a="http://schemas.openxmlformats.org/drawingml/2006/main"/>
           <a:p xmlns:a="http://schemas.openxmlformats.org/drawingml/2006/main">
             <a:pPr algn="l">
+              <a:buNone/>
               <a:defRPr sz="1725" b="1">
                 <a:solidFill>
                   <a:srgbClr val="0D1117"/>
@@ -7724,6 +7962,7 @@
           <a:lstStyle xmlns:a="http://schemas.openxmlformats.org/drawingml/2006/main"/>
           <a:p xmlns:a="http://schemas.openxmlformats.org/drawingml/2006/main">
             <a:pPr algn="l">
+              <a:buNone/>
               <a:defRPr sz="1350" b="0">
                 <a:solidFill>
                   <a:srgbClr val="57606A"/>
@@ -7807,6 +8046,7 @@
           <a:lstStyle xmlns:a="http://schemas.openxmlformats.org/drawingml/2006/main"/>
           <a:p xmlns:a="http://schemas.openxmlformats.org/drawingml/2006/main">
             <a:pPr algn="l">
+              <a:buNone/>
               <a:defRPr sz="1725" b="1">
                 <a:solidFill>
                   <a:srgbClr val="0D1117"/>
@@ -7857,6 +8097,7 @@
           <a:lstStyle xmlns:a="http://schemas.openxmlformats.org/drawingml/2006/main"/>
           <a:p xmlns:a="http://schemas.openxmlformats.org/drawingml/2006/main">
             <a:pPr algn="l">
+              <a:buNone/>
               <a:defRPr sz="1350" b="0">
                 <a:solidFill>
                   <a:srgbClr val="57606A"/>
@@ -7940,6 +8181,7 @@
           <a:lstStyle xmlns:a="http://schemas.openxmlformats.org/drawingml/2006/main"/>
           <a:p xmlns:a="http://schemas.openxmlformats.org/drawingml/2006/main">
             <a:pPr algn="l">
+              <a:buNone/>
               <a:defRPr sz="1725" b="1">
                 <a:solidFill>
                   <a:srgbClr val="0D1117"/>
@@ -7990,6 +8232,7 @@
           <a:lstStyle xmlns:a="http://schemas.openxmlformats.org/drawingml/2006/main"/>
           <a:p xmlns:a="http://schemas.openxmlformats.org/drawingml/2006/main">
             <a:pPr algn="l">
+              <a:buNone/>
               <a:defRPr sz="1350" b="0">
                 <a:solidFill>
                   <a:srgbClr val="57606A"/>
@@ -8073,6 +8316,7 @@
           <a:lstStyle xmlns:a="http://schemas.openxmlformats.org/drawingml/2006/main"/>
           <a:p xmlns:a="http://schemas.openxmlformats.org/drawingml/2006/main">
             <a:pPr algn="l">
+              <a:buNone/>
               <a:defRPr sz="1725" b="1">
                 <a:solidFill>
                   <a:srgbClr val="0D1117"/>
@@ -8085,7 +8329,7 @@
                   <a:srgbClr val="0D1117"/>
                 </a:solidFill>
               </a:rPr>
-              <a:t>版本不漂移</a:t>
+              <a:t>漏洞套件已清除</a:t>
             </a:r>
           </a:p>
         </p:txBody>
@@ -8123,6 +8367,7 @@
           <a:lstStyle xmlns:a="http://schemas.openxmlformats.org/drawingml/2006/main"/>
           <a:p xmlns:a="http://schemas.openxmlformats.org/drawingml/2006/main">
             <a:pPr algn="l">
+              <a:buNone/>
               <a:defRPr sz="1350" b="0">
                 <a:solidFill>
                   <a:srgbClr val="57606A"/>
@@ -8135,7 +8380,7 @@
                   <a:srgbClr val="57606A"/>
                 </a:solidFill>
               </a:rPr>
-              <a:t>IdentityModel、.NET、Mongo image 固定</a:t>
+              <a:t>NuGet 已知漏洞 0；前端 High／Critical 0</a:t>
             </a:r>
           </a:p>
         </p:txBody>
@@ -8206,6 +8451,7 @@
           <a:lstStyle xmlns:a="http://schemas.openxmlformats.org/drawingml/2006/main"/>
           <a:p xmlns:a="http://schemas.openxmlformats.org/drawingml/2006/main">
             <a:pPr algn="l">
+              <a:buNone/>
               <a:defRPr sz="1725" b="1">
                 <a:solidFill>
                   <a:srgbClr val="0D1117"/>
@@ -8218,7 +8464,7 @@
                   <a:srgbClr val="0D1117"/>
                 </a:solidFill>
               </a:rPr>
-              <a:t>健康狀態可區分</a:t>
+              <a:t>健康與供應鏈可驗證</a:t>
             </a:r>
           </a:p>
         </p:txBody>
@@ -8256,6 +8502,7 @@
           <a:lstStyle xmlns:a="http://schemas.openxmlformats.org/drawingml/2006/main"/>
           <a:p xmlns:a="http://schemas.openxmlformats.org/drawingml/2006/main">
             <a:pPr algn="l">
+              <a:buNone/>
               <a:defRPr sz="1350" b="0">
                 <a:solidFill>
                   <a:srgbClr val="57606A"/>
@@ -8268,7 +8515,7 @@
                   <a:srgbClr val="57606A"/>
                 </a:solidFill>
               </a:rPr>
-              <a:t>live 與 ready 分離</a:t>
+              <a:t>live／ready 分離，版本與 lockfile 固定</a:t>
             </a:r>
           </a:p>
         </p:txBody>
@@ -8335,6 +8582,7 @@
           <a:lstStyle xmlns:a="http://schemas.openxmlformats.org/drawingml/2006/main"/>
           <a:p xmlns:a="http://schemas.openxmlformats.org/drawingml/2006/main">
             <a:pPr algn="l">
+              <a:buNone/>
               <a:defRPr sz="1050" b="1">
                 <a:solidFill>
                   <a:srgbClr val="1F883D"/>
@@ -8385,6 +8633,7 @@
           <a:lstStyle xmlns:a="http://schemas.openxmlformats.org/drawingml/2006/main"/>
           <a:p xmlns:a="http://schemas.openxmlformats.org/drawingml/2006/main">
             <a:pPr algn="l">
+              <a:buNone/>
               <a:defRPr sz="3600" b="1">
                 <a:solidFill>
                   <a:srgbClr val="0D1117"/>
@@ -8397,7 +8646,7 @@
                   <a:srgbClr val="0D1117"/>
                 </a:solidFill>
               </a:rPr>
-              <a:t>品質閘門已用 CI 證據驗證，不只停留在文件</a:t>
+              <a:t>關鍵品質閘門已在本機完整驗證，並納入 CI</a:t>
             </a:r>
           </a:p>
         </p:txBody>
@@ -8466,6 +8715,7 @@
           <a:lstStyle xmlns:a="http://schemas.openxmlformats.org/drawingml/2006/main"/>
           <a:p xmlns:a="http://schemas.openxmlformats.org/drawingml/2006/main">
             <a:pPr algn="l">
+              <a:buNone/>
               <a:defRPr sz="900" b="0">
                 <a:solidFill>
                   <a:srgbClr val="57606A"/>
@@ -8516,6 +8766,7 @@
           <a:lstStyle xmlns:a="http://schemas.openxmlformats.org/drawingml/2006/main"/>
           <a:p xmlns:a="http://schemas.openxmlformats.org/drawingml/2006/main">
             <a:pPr algn="r">
+              <a:buNone/>
               <a:defRPr sz="1050" b="1">
                 <a:solidFill>
                   <a:srgbClr val="57606A"/>
@@ -8599,6 +8850,7 @@
           <a:lstStyle xmlns:a="http://schemas.openxmlformats.org/drawingml/2006/main"/>
           <a:p xmlns:a="http://schemas.openxmlformats.org/drawingml/2006/main">
             <a:pPr algn="l">
+              <a:buNone/>
               <a:defRPr sz="3300" b="1">
                 <a:solidFill>
                   <a:srgbClr val="1F883D"/>
@@ -8611,7 +8863,7 @@
                   <a:srgbClr val="1F883D"/>
                 </a:solidFill>
               </a:rPr>
-              <a:t>全綠</a:t>
+              <a:t>已設定</a:t>
             </a:r>
           </a:p>
         </p:txBody>
@@ -8649,6 +8901,7 @@
           <a:lstStyle xmlns:a="http://schemas.openxmlformats.org/drawingml/2006/main"/>
           <a:p xmlns:a="http://schemas.openxmlformats.org/drawingml/2006/main">
             <a:pPr algn="l">
+              <a:buNone/>
               <a:defRPr sz="1350" b="1">
                 <a:solidFill>
                   <a:srgbClr val="57606A"/>
@@ -8732,6 +8985,7 @@
           <a:lstStyle xmlns:a="http://schemas.openxmlformats.org/drawingml/2006/main"/>
           <a:p xmlns:a="http://schemas.openxmlformats.org/drawingml/2006/main">
             <a:pPr algn="l">
+              <a:buNone/>
               <a:defRPr sz="3300" b="1">
                 <a:solidFill>
                   <a:srgbClr val="0969DA"/>
@@ -8744,7 +8998,7 @@
                   <a:srgbClr val="0969DA"/>
                 </a:solidFill>
               </a:rPr>
-              <a:t>Build + Test</a:t>
+              <a:t>158／158</a:t>
             </a:r>
           </a:p>
         </p:txBody>
@@ -8782,6 +9036,7 @@
           <a:lstStyle xmlns:a="http://schemas.openxmlformats.org/drawingml/2006/main"/>
           <a:p xmlns:a="http://schemas.openxmlformats.org/drawingml/2006/main">
             <a:pPr algn="l">
+              <a:buNone/>
               <a:defRPr sz="1350" b="1">
                 <a:solidFill>
                   <a:srgbClr val="57606A"/>
@@ -8865,6 +9120,7 @@
           <a:lstStyle xmlns:a="http://schemas.openxmlformats.org/drawingml/2006/main"/>
           <a:p xmlns:a="http://schemas.openxmlformats.org/drawingml/2006/main">
             <a:pPr algn="l">
+              <a:buNone/>
               <a:defRPr sz="3300" b="1">
                 <a:solidFill>
                   <a:srgbClr val="0969DA"/>
@@ -8877,7 +9133,7 @@
                   <a:srgbClr val="0969DA"/>
                 </a:solidFill>
               </a:rPr>
-              <a:t>Lint + Build</a:t>
+              <a:t>54／54</a:t>
             </a:r>
           </a:p>
         </p:txBody>
@@ -8915,6 +9171,7 @@
           <a:lstStyle xmlns:a="http://schemas.openxmlformats.org/drawingml/2006/main"/>
           <a:p xmlns:a="http://schemas.openxmlformats.org/drawingml/2006/main">
             <a:pPr algn="l">
+              <a:buNone/>
               <a:defRPr sz="1350" b="1">
                 <a:solidFill>
                   <a:srgbClr val="57606A"/>
@@ -8965,6 +9222,7 @@
           <a:lstStyle xmlns:a="http://schemas.openxmlformats.org/drawingml/2006/main"/>
           <a:p xmlns:a="http://schemas.openxmlformats.org/drawingml/2006/main">
             <a:pPr algn="l">
+              <a:buNone/>
               <a:defRPr sz="1650" b="0">
                 <a:solidFill>
                   <a:srgbClr val="0D1117"/>
@@ -8977,7 +9235,7 @@
                   <a:srgbClr val="0D1117"/>
                 </a:solidFill>
               </a:rPr>
-              <a:t>•  xUnit：Refresh hash、token family、JWT user ID、Argon2id</a:t>
+              <a:t>•  .NET 10：158 項安全／架構／整合測試全數通過</a:t>
             </a:r>
           </a:p>
         </p:txBody>
@@ -9015,6 +9273,7 @@
           <a:lstStyle xmlns:a="http://schemas.openxmlformats.org/drawingml/2006/main"/>
           <a:p xmlns:a="http://schemas.openxmlformats.org/drawingml/2006/main">
             <a:pPr algn="l">
+              <a:buNone/>
               <a:defRPr sz="1650" b="0">
                 <a:solidFill>
                   <a:srgbClr val="0D1117"/>
@@ -9027,7 +9286,7 @@
                   <a:srgbClr val="0D1117"/>
                 </a:solidFill>
               </a:rPr>
-              <a:t>•  API integration：匿名 health、未登入拒絕、無 CSRF 寫入拒絕</a:t>
+              <a:t>•  Frontend：54 項測試、ESLint、Next.js production build 通過</a:t>
             </a:r>
           </a:p>
         </p:txBody>
@@ -9065,6 +9324,7 @@
           <a:lstStyle xmlns:a="http://schemas.openxmlformats.org/drawingml/2006/main"/>
           <a:p xmlns:a="http://schemas.openxmlformats.org/drawingml/2006/main">
             <a:pPr algn="l">
+              <a:buNone/>
               <a:defRPr sz="1650" b="0">
                 <a:solidFill>
                   <a:srgbClr val="0D1117"/>
@@ -9077,7 +9337,7 @@
                   <a:srgbClr val="0D1117"/>
                 </a:solidFill>
               </a:rPr>
-              <a:t>•  Production build：Next.js TypeScript 與靜態頁面產出成功</a:t>
+              <a:t>•  供應鏈：NuGet 漏洞 0；pnpm High／Critical 0</a:t>
             </a:r>
           </a:p>
         </p:txBody>
@@ -9115,6 +9375,7 @@
           <a:lstStyle xmlns:a="http://schemas.openxmlformats.org/drawingml/2006/main"/>
           <a:p xmlns:a="http://schemas.openxmlformats.org/drawingml/2006/main">
             <a:pPr algn="l">
+              <a:buNone/>
               <a:defRPr sz="1350" b="1">
                 <a:solidFill>
                   <a:srgbClr val="57606A"/>
@@ -9127,7 +9388,7 @@
                   <a:srgbClr val="57606A"/>
                 </a:solidFill>
               </a:rPr>
-              <a:t>驗證紀錄：GitHub Actions run 30022585388</a:t>
+              <a:t>本機：.NET 158／158｜Vitest 54／54｜Next build ✓</a:t>
             </a:r>
           </a:p>
         </p:txBody>
@@ -9194,6 +9455,7 @@
           <a:lstStyle xmlns:a="http://schemas.openxmlformats.org/drawingml/2006/main"/>
           <a:p xmlns:a="http://schemas.openxmlformats.org/drawingml/2006/main">
             <a:pPr algn="l">
+              <a:buNone/>
               <a:defRPr sz="1050" b="1">
                 <a:solidFill>
                   <a:srgbClr val="1F883D"/>
@@ -9244,6 +9506,7 @@
           <a:lstStyle xmlns:a="http://schemas.openxmlformats.org/drawingml/2006/main"/>
           <a:p xmlns:a="http://schemas.openxmlformats.org/drawingml/2006/main">
             <a:pPr algn="l">
+              <a:buNone/>
               <a:defRPr sz="3600" b="1">
                 <a:solidFill>
                   <a:srgbClr val="0D1117"/>
@@ -9325,6 +9588,7 @@
           <a:lstStyle xmlns:a="http://schemas.openxmlformats.org/drawingml/2006/main"/>
           <a:p xmlns:a="http://schemas.openxmlformats.org/drawingml/2006/main">
             <a:pPr algn="l">
+              <a:buNone/>
               <a:defRPr sz="900" b="0">
                 <a:solidFill>
                   <a:srgbClr val="57606A"/>
@@ -9375,6 +9639,7 @@
           <a:lstStyle xmlns:a="http://schemas.openxmlformats.org/drawingml/2006/main"/>
           <a:p xmlns:a="http://schemas.openxmlformats.org/drawingml/2006/main">
             <a:pPr algn="r">
+              <a:buNone/>
               <a:defRPr sz="1050" b="1">
                 <a:solidFill>
                   <a:srgbClr val="57606A"/>
@@ -9425,6 +9690,7 @@
           <a:lstStyle xmlns:a="http://schemas.openxmlformats.org/drawingml/2006/main"/>
           <a:p xmlns:a="http://schemas.openxmlformats.org/drawingml/2006/main">
             <a:pPr algn="l">
+              <a:buNone/>
               <a:defRPr sz="1575" b="1">
                 <a:solidFill>
                   <a:srgbClr val="CF222E"/>
@@ -9475,6 +9741,7 @@
           <a:lstStyle xmlns:a="http://schemas.openxmlformats.org/drawingml/2006/main"/>
           <a:p xmlns:a="http://schemas.openxmlformats.org/drawingml/2006/main">
             <a:pPr algn="l">
+              <a:buNone/>
               <a:defRPr sz="1575" b="0">
                 <a:solidFill>
                   <a:srgbClr val="0D1117"/>
@@ -9556,6 +9823,7 @@
           <a:lstStyle xmlns:a="http://schemas.openxmlformats.org/drawingml/2006/main"/>
           <a:p xmlns:a="http://schemas.openxmlformats.org/drawingml/2006/main">
             <a:pPr algn="l">
+              <a:buNone/>
               <a:defRPr sz="1575" b="1">
                 <a:solidFill>
                   <a:srgbClr val="CF222E"/>
@@ -9606,6 +9874,7 @@
           <a:lstStyle xmlns:a="http://schemas.openxmlformats.org/drawingml/2006/main"/>
           <a:p xmlns:a="http://schemas.openxmlformats.org/drawingml/2006/main">
             <a:pPr algn="l">
+              <a:buNone/>
               <a:defRPr sz="1575" b="0">
                 <a:solidFill>
                   <a:srgbClr val="0D1117"/>
@@ -9687,6 +9956,7 @@
           <a:lstStyle xmlns:a="http://schemas.openxmlformats.org/drawingml/2006/main"/>
           <a:p xmlns:a="http://schemas.openxmlformats.org/drawingml/2006/main">
             <a:pPr algn="l">
+              <a:buNone/>
               <a:defRPr sz="1575" b="1">
                 <a:solidFill>
                   <a:srgbClr val="BF8700"/>
@@ -9737,6 +10007,7 @@
           <a:lstStyle xmlns:a="http://schemas.openxmlformats.org/drawingml/2006/main"/>
           <a:p xmlns:a="http://schemas.openxmlformats.org/drawingml/2006/main">
             <a:pPr algn="l">
+              <a:buNone/>
               <a:defRPr sz="1575" b="0">
                 <a:solidFill>
                   <a:srgbClr val="0D1117"/>
@@ -9818,6 +10089,7 @@
           <a:lstStyle xmlns:a="http://schemas.openxmlformats.org/drawingml/2006/main"/>
           <a:p xmlns:a="http://schemas.openxmlformats.org/drawingml/2006/main">
             <a:pPr algn="l">
+              <a:buNone/>
               <a:defRPr sz="1575" b="1">
                 <a:solidFill>
                   <a:srgbClr val="BF8700"/>
@@ -9868,6 +10140,7 @@
           <a:lstStyle xmlns:a="http://schemas.openxmlformats.org/drawingml/2006/main"/>
           <a:p xmlns:a="http://schemas.openxmlformats.org/drawingml/2006/main">
             <a:pPr algn="l">
+              <a:buNone/>
               <a:defRPr sz="1575" b="0">
                 <a:solidFill>
                   <a:srgbClr val="0D1117"/>
@@ -9949,6 +10222,7 @@
           <a:lstStyle xmlns:a="http://schemas.openxmlformats.org/drawingml/2006/main"/>
           <a:p xmlns:a="http://schemas.openxmlformats.org/drawingml/2006/main">
             <a:pPr algn="l">
+              <a:buNone/>
               <a:defRPr sz="1575" b="1">
                 <a:solidFill>
                   <a:srgbClr val="BF8700"/>
@@ -9961,7 +10235,7 @@
                   <a:srgbClr val="BF8700"/>
                 </a:solidFill>
               </a:rPr>
-              <a:t>供應鏈治理</a:t>
+              <a:t>治理責任</a:t>
             </a:r>
           </a:p>
         </p:txBody>
@@ -9999,6 +10273,7 @@
           <a:lstStyle xmlns:a="http://schemas.openxmlformats.org/drawingml/2006/main"/>
           <a:p xmlns:a="http://schemas.openxmlformats.org/drawingml/2006/main">
             <a:pPr algn="l">
+              <a:buNone/>
               <a:defRPr sz="1575" b="0">
                 <a:solidFill>
                   <a:srgbClr val="0D1117"/>
@@ -10011,7 +10286,7 @@
                   <a:srgbClr val="0D1117"/>
                 </a:solidFill>
               </a:rPr>
-              <a:t>CodeQL、SBOM、image scan、更新機器人</a:t>
+              <a:t>Branch protection、權限定期審查、變更核准</a:t>
             </a:r>
           </a:p>
         </p:txBody>
@@ -10080,6 +10355,7 @@
           <a:lstStyle xmlns:a="http://schemas.openxmlformats.org/drawingml/2006/main"/>
           <a:p xmlns:a="http://schemas.openxmlformats.org/drawingml/2006/main">
             <a:pPr algn="l">
+              <a:buNone/>
               <a:defRPr sz="1575" b="1">
                 <a:solidFill>
                   <a:srgbClr val="BF8700"/>
@@ -10130,6 +10406,7 @@
           <a:lstStyle xmlns:a="http://schemas.openxmlformats.org/drawingml/2006/main"/>
           <a:p xmlns:a="http://schemas.openxmlformats.org/drawingml/2006/main">
             <a:pPr algn="l">
+              <a:buNone/>
               <a:defRPr sz="1575" b="0">
                 <a:solidFill>
                   <a:srgbClr val="0D1117"/>
@@ -10240,6 +10517,7 @@
           <a:lstStyle xmlns:a="http://schemas.openxmlformats.org/drawingml/2006/main"/>
           <a:p xmlns:a="http://schemas.openxmlformats.org/drawingml/2006/main">
             <a:pPr algn="l">
+              <a:buNone/>
               <a:defRPr sz="1050" b="1">
                 <a:solidFill>
                   <a:srgbClr val="1F883D"/>
@@ -10290,6 +10568,7 @@
           <a:lstStyle xmlns:a="http://schemas.openxmlformats.org/drawingml/2006/main"/>
           <a:p xmlns:a="http://schemas.openxmlformats.org/drawingml/2006/main">
             <a:pPr algn="l">
+              <a:buNone/>
               <a:defRPr sz="3600" b="1">
                 <a:solidFill>
                   <a:srgbClr val="0D1117"/>
@@ -10371,6 +10650,7 @@
           <a:lstStyle xmlns:a="http://schemas.openxmlformats.org/drawingml/2006/main"/>
           <a:p xmlns:a="http://schemas.openxmlformats.org/drawingml/2006/main">
             <a:pPr algn="l">
+              <a:buNone/>
               <a:defRPr sz="900" b="0">
                 <a:solidFill>
                   <a:srgbClr val="57606A"/>
@@ -10421,6 +10701,7 @@
           <a:lstStyle xmlns:a="http://schemas.openxmlformats.org/drawingml/2006/main"/>
           <a:p xmlns:a="http://schemas.openxmlformats.org/drawingml/2006/main">
             <a:pPr algn="r">
+              <a:buNone/>
               <a:defRPr sz="1050" b="1">
                 <a:solidFill>
                   <a:srgbClr val="57606A"/>
@@ -10535,6 +10816,7 @@
           <a:lstStyle xmlns:a="http://schemas.openxmlformats.org/drawingml/2006/main"/>
           <a:p xmlns:a="http://schemas.openxmlformats.org/drawingml/2006/main">
             <a:pPr algn="l">
+              <a:buNone/>
               <a:defRPr sz="2025" b="1">
                 <a:solidFill>
                   <a:srgbClr val="CF222E"/>
@@ -10585,6 +10867,7 @@
           <a:lstStyle xmlns:a="http://schemas.openxmlformats.org/drawingml/2006/main"/>
           <a:p xmlns:a="http://schemas.openxmlformats.org/drawingml/2006/main">
             <a:pPr algn="l">
+              <a:buNone/>
               <a:defRPr sz="1650" b="0">
                 <a:solidFill>
                   <a:srgbClr val="0D1117"/>
@@ -10635,6 +10918,7 @@
           <a:lstStyle xmlns:a="http://schemas.openxmlformats.org/drawingml/2006/main"/>
           <a:p xmlns:a="http://schemas.openxmlformats.org/drawingml/2006/main">
             <a:pPr algn="l">
+              <a:buNone/>
               <a:defRPr sz="1650" b="0">
                 <a:solidFill>
                   <a:srgbClr val="0D1117"/>
@@ -10685,6 +10969,7 @@
           <a:lstStyle xmlns:a="http://schemas.openxmlformats.org/drawingml/2006/main"/>
           <a:p xmlns:a="http://schemas.openxmlformats.org/drawingml/2006/main">
             <a:pPr algn="l">
+              <a:buNone/>
               <a:defRPr sz="1650" b="0">
                 <a:solidFill>
                   <a:srgbClr val="0D1117"/>
@@ -10735,6 +11020,7 @@
           <a:lstStyle xmlns:a="http://schemas.openxmlformats.org/drawingml/2006/main"/>
           <a:p xmlns:a="http://schemas.openxmlformats.org/drawingml/2006/main">
             <a:pPr algn="l">
+              <a:buNone/>
               <a:defRPr sz="1650" b="0">
                 <a:solidFill>
                   <a:srgbClr val="0D1117"/>
@@ -10849,6 +11135,7 @@
           <a:lstStyle xmlns:a="http://schemas.openxmlformats.org/drawingml/2006/main"/>
           <a:p xmlns:a="http://schemas.openxmlformats.org/drawingml/2006/main">
             <a:pPr algn="l">
+              <a:buNone/>
               <a:defRPr sz="2025" b="1">
                 <a:solidFill>
                   <a:srgbClr val="BF8700"/>
@@ -10899,6 +11186,7 @@
           <a:lstStyle xmlns:a="http://schemas.openxmlformats.org/drawingml/2006/main"/>
           <a:p xmlns:a="http://schemas.openxmlformats.org/drawingml/2006/main">
             <a:pPr algn="l">
+              <a:buNone/>
               <a:defRPr sz="1650" b="0">
                 <a:solidFill>
                   <a:srgbClr val="0D1117"/>
@@ -10911,7 +11199,7 @@
                   <a:srgbClr val="0D1117"/>
                 </a:solidFill>
               </a:rPr>
-              <a:t>•  Playwright E2E</a:t>
+              <a:t>•  真實環境 E2E</a:t>
             </a:r>
           </a:p>
         </p:txBody>
@@ -10949,6 +11237,7 @@
           <a:lstStyle xmlns:a="http://schemas.openxmlformats.org/drawingml/2006/main"/>
           <a:p xmlns:a="http://schemas.openxmlformats.org/drawingml/2006/main">
             <a:pPr algn="l">
+              <a:buNone/>
               <a:defRPr sz="1650" b="0">
                 <a:solidFill>
                   <a:srgbClr val="0D1117"/>
@@ -10961,7 +11250,7 @@
                   <a:srgbClr val="0D1117"/>
                 </a:solidFill>
               </a:rPr>
-              <a:t>•  Auth Application Service</a:t>
+              <a:t>•  Branch protection</a:t>
             </a:r>
           </a:p>
         </p:txBody>
@@ -10999,6 +11288,7 @@
           <a:lstStyle xmlns:a="http://schemas.openxmlformats.org/drawingml/2006/main"/>
           <a:p xmlns:a="http://schemas.openxmlformats.org/drawingml/2006/main">
             <a:pPr algn="l">
+              <a:buNone/>
               <a:defRPr sz="1650" b="0">
                 <a:solidFill>
                   <a:srgbClr val="0D1117"/>
@@ -11011,7 +11301,7 @@
                   <a:srgbClr val="0D1117"/>
                 </a:solidFill>
               </a:rPr>
-              <a:t>•  CodeQL／SBOM</a:t>
+              <a:t>•  權限定期審查</a:t>
             </a:r>
           </a:p>
         </p:txBody>
@@ -11049,6 +11339,7 @@
           <a:lstStyle xmlns:a="http://schemas.openxmlformats.org/drawingml/2006/main"/>
           <a:p xmlns:a="http://schemas.openxmlformats.org/drawingml/2006/main">
             <a:pPr algn="l">
+              <a:buNone/>
               <a:defRPr sz="1650" b="0">
                 <a:solidFill>
                   <a:srgbClr val="0D1117"/>
@@ -11061,7 +11352,7 @@
                   <a:srgbClr val="0D1117"/>
                 </a:solidFill>
               </a:rPr>
-              <a:t>•  Branch protection</a:t>
+              <a:t>•  告警值班流程</a:t>
             </a:r>
           </a:p>
         </p:txBody>
@@ -11163,6 +11454,7 @@
           <a:lstStyle xmlns:a="http://schemas.openxmlformats.org/drawingml/2006/main"/>
           <a:p xmlns:a="http://schemas.openxmlformats.org/drawingml/2006/main">
             <a:pPr algn="l">
+              <a:buNone/>
               <a:defRPr sz="2025" b="1">
                 <a:solidFill>
                   <a:srgbClr val="1F883D"/>
@@ -11213,6 +11505,7 @@
           <a:lstStyle xmlns:a="http://schemas.openxmlformats.org/drawingml/2006/main"/>
           <a:p xmlns:a="http://schemas.openxmlformats.org/drawingml/2006/main">
             <a:pPr algn="l">
+              <a:buNone/>
               <a:defRPr sz="1650" b="0">
                 <a:solidFill>
                   <a:srgbClr val="0D1117"/>
@@ -11225,7 +11518,7 @@
                   <a:srgbClr val="0D1117"/>
                 </a:solidFill>
               </a:rPr>
-              <a:t>•  CSP nonce</a:t>
+              <a:t>•  容量與壓力測試</a:t>
             </a:r>
           </a:p>
         </p:txBody>
@@ -11263,6 +11556,7 @@
           <a:lstStyle xmlns:a="http://schemas.openxmlformats.org/drawingml/2006/main"/>
           <a:p xmlns:a="http://schemas.openxmlformats.org/drawingml/2006/main">
             <a:pPr algn="l">
+              <a:buNone/>
               <a:defRPr sz="1650" b="0">
                 <a:solidFill>
                   <a:srgbClr val="0D1117"/>
@@ -11275,7 +11569,7 @@
                   <a:srgbClr val="0D1117"/>
                 </a:solidFill>
               </a:rPr>
-              <a:t>•  容量與壓力測試</a:t>
+              <a:t>•  SLO／錯誤預算</a:t>
             </a:r>
           </a:p>
         </p:txBody>
@@ -11313,6 +11607,7 @@
           <a:lstStyle xmlns:a="http://schemas.openxmlformats.org/drawingml/2006/main"/>
           <a:p xmlns:a="http://schemas.openxmlformats.org/drawingml/2006/main">
             <a:pPr algn="l">
+              <a:buNone/>
               <a:defRPr sz="1650" b="0">
                 <a:solidFill>
                   <a:srgbClr val="0D1117"/>
@@ -11325,7 +11620,7 @@
                   <a:srgbClr val="0D1117"/>
                 </a:solidFill>
               </a:rPr>
-              <a:t>•  SLO／錯誤預算</a:t>
+              <a:t>•  年度威脅模型</a:t>
             </a:r>
           </a:p>
         </p:txBody>
@@ -11363,6 +11658,7 @@
           <a:lstStyle xmlns:a="http://schemas.openxmlformats.org/drawingml/2006/main"/>
           <a:p xmlns:a="http://schemas.openxmlformats.org/drawingml/2006/main">
             <a:pPr algn="l">
+              <a:buNone/>
               <a:defRPr sz="1650" b="0">
                 <a:solidFill>
                   <a:srgbClr val="0D1117"/>
@@ -11375,7 +11671,7 @@
                   <a:srgbClr val="0D1117"/>
                 </a:solidFill>
               </a:rPr>
-              <a:t>•  年度威脅模型</a:t>
+              <a:t>•  獨立滲透測試</a:t>
             </a:r>
           </a:p>
         </p:txBody>

</xml_diff>